<commit_message>
SIH deck: add team members and mentor to the title page
Co-Authored-By: Claude Opus 5.5 <noreply@anthropic.com>
</commit_message>
<xml_diff>
--- a/presentation/RoadPulse_SIH2026_PS26153.pptx
+++ b/presentation/RoadPulse_SIH2026_PS26153.pptx
@@ -6464,6 +6464,88 @@
           </a:prstGeom>
         </p:spPr>
       </p:pic>
+      <p:sp>
+        <p:nvSpPr>
+          <p:cNvPr id="38" name="TextBox 37"/>
+          <p:cNvSpPr txBox="1"/>
+          <p:nvPr/>
+        </p:nvSpPr>
+        <p:spPr>
+          <a:xfrm>
+            <a:off x="411480" y="5623560"/>
+            <a:ext cx="6583680" cy="868680"/>
+          </a:xfrm>
+          <a:prstGeom prst="rect">
+            <a:avLst/>
+          </a:prstGeom>
+          <a:noFill/>
+        </p:spPr>
+        <p:txBody>
+          <a:bodyPr wrap="square" lIns="0" rIns="0" tIns="0" bIns="0" anchor="t">
+            <a:spAutoFit/>
+          </a:bodyPr>
+          <a:lstStyle/>
+          <a:p>
+            <a:pPr algn="l">
+              <a:spcAft>
+                <a:spcPts val="400"/>
+              </a:spcAft>
+            </a:pPr>
+            <a:r>
+              <a:rPr sz="1100" b="1" i="0">
+                <a:solidFill>
+                  <a:srgbClr val="1F3864"/>
+                </a:solidFill>
+                <a:latin typeface="Arial"/>
+              </a:rPr>
+              <a:t>Team: </a:t>
+            </a:r>
+            <a:r>
+              <a:rPr sz="1100" b="0" i="0">
+                <a:solidFill>
+                  <a:srgbClr val="1A1A1A"/>
+                </a:solidFill>
+                <a:latin typeface="Arial"/>
+              </a:rPr>
+              <a:t>Palak Harbola (Leader) · Yash Kumar · Ansh Pratap Singh · Aditya Sharma · Tamandeep Singh Bhatia · Atiksh Gupta</a:t>
+            </a:r>
+          </a:p>
+          <a:p>
+            <a:pPr algn="l">
+              <a:spcAft>
+                <a:spcPts val="400"/>
+              </a:spcAft>
+            </a:pPr>
+            <a:r>
+              <a:rPr sz="1100" b="1" i="0">
+                <a:solidFill>
+                  <a:srgbClr val="1F3864"/>
+                </a:solidFill>
+                <a:latin typeface="Arial"/>
+              </a:rPr>
+              <a:t>Mentor: </a:t>
+            </a:r>
+            <a:r>
+              <a:rPr sz="1100" b="0" i="0">
+                <a:solidFill>
+                  <a:srgbClr val="1A1A1A"/>
+                </a:solidFill>
+                <a:latin typeface="Arial"/>
+              </a:rPr>
+              <a:t>Dr. Amitesh Pandey</a:t>
+            </a:r>
+            <a:r>
+              <a:rPr sz="1100" b="0" i="0">
+                <a:solidFill>
+                  <a:srgbClr val="595959"/>
+                </a:solidFill>
+                <a:latin typeface="Arial"/>
+              </a:rPr>
+              <a:t>   |   B.Tech, 3rd year, JIIT</a:t>
+            </a:r>
+          </a:p>
+        </p:txBody>
+      </p:sp>
     </p:spTree>
   </p:cSld>
   <p:clrMapOvr>

</xml_diff>